<commit_message>
Fix Project 2 gallery: Super Duper -> fake_finder.html (real security checker, not the dummy-feed stub); Fixr Findr -> repo root (real Vite build, not the unbuilt code_deliverable index) + value = sustainability & transparency (stated in their ethical reflection)
Co-Authored-By: Claude Fable 5 <noreply@anthropic.com>
</commit_message>
<xml_diff>
--- a/slides/team-decks/Week3-Tue-guantanamo-bay-wendys.pptx
+++ b/slides/team-decks/Week3-Tue-guantanamo-bay-wendys.pptx
@@ -4199,11 +4199,11 @@
             <a:r>
               <a:rPr sz="4600" b="1">
                 <a:solidFill>
-                  <a:srgbClr val="8A94A6"/>
-                </a:solidFill>
-                <a:latin typeface="Arial"/>
-              </a:rPr>
-              <a:t>[ name your team after your value ]</a:t>
+                  <a:srgbClr val="F5F7FA"/>
+                </a:solidFill>
+                <a:latin typeface="Arial"/>
+              </a:rPr>
+              <a:t>The Sustainability &amp; Transparency Team</a:t>
             </a:r>
           </a:p>
         </p:txBody>
@@ -4290,7 +4290,7 @@
                 </a:solidFill>
                 <a:latin typeface="Arial"/>
               </a:rPr>
-              <a:t>Fixr Findr</a:t>
+              <a:t>Fixr Findr - fix-or-replace: repair cost + CO2 saved</a:t>
             </a:r>
           </a:p>
         </p:txBody>

</xml_diff>